<commit_message>
Add Price Action documentation with Candle without Wig concept and image
</commit_message>
<xml_diff>
--- a/docs/assets/Concepts/Concepts.pptx
+++ b/docs/assets/Concepts/Concepts.pptx
@@ -5,10 +5,11 @@
     <p:sldMasterId id="2147483648" r:id="rId1"/>
   </p:sldMasterIdLst>
   <p:notesMasterIdLst>
-    <p:notesMasterId r:id="rId3"/>
+    <p:notesMasterId r:id="rId4"/>
   </p:notesMasterIdLst>
   <p:sldIdLst>
     <p:sldId id="256" r:id="rId2"/>
+    <p:sldId id="257" r:id="rId3"/>
   </p:sldIdLst>
   <p:sldSz cx="12192000" cy="6858000"/>
   <p:notesSz cx="6858000" cy="9144000"/>
@@ -542,6 +543,93 @@
     <p:extLst>
       <p:ext uri="{BB962C8B-B14F-4D97-AF65-F5344CB8AC3E}">
         <p14:creationId xmlns:p14="http://schemas.microsoft.com/office/powerpoint/2010/main" val="3078474456"/>
+      </p:ext>
+    </p:extLst>
+  </p:cSld>
+  <p:clrMapOvr>
+    <a:masterClrMapping/>
+  </p:clrMapOvr>
+</p:notes>
+</file>
+
+<file path=ppt/notesSlides/notesSlide2.xml><?xml version="1.0" encoding="utf-8"?>
+<p:notes xmlns:a="http://schemas.openxmlformats.org/drawingml/2006/main" xmlns:r="http://schemas.openxmlformats.org/officeDocument/2006/relationships" xmlns:p="http://schemas.openxmlformats.org/presentationml/2006/main">
+  <p:cSld>
+    <p:spTree>
+      <p:nvGrpSpPr>
+        <p:cNvPr id="1" name=""/>
+        <p:cNvGrpSpPr/>
+        <p:nvPr/>
+      </p:nvGrpSpPr>
+      <p:grpSpPr>
+        <a:xfrm>
+          <a:off x="0" y="0"/>
+          <a:ext cx="0" cy="0"/>
+          <a:chOff x="0" y="0"/>
+          <a:chExt cx="0" cy="0"/>
+        </a:xfrm>
+      </p:grpSpPr>
+      <p:sp>
+        <p:nvSpPr>
+          <p:cNvPr id="2" name="Slide Image Placeholder 1"/>
+          <p:cNvSpPr>
+            <a:spLocks noGrp="1" noRot="1" noChangeAspect="1"/>
+          </p:cNvSpPr>
+          <p:nvPr>
+            <p:ph type="sldImg"/>
+          </p:nvPr>
+        </p:nvSpPr>
+        <p:spPr/>
+      </p:sp>
+      <p:sp>
+        <p:nvSpPr>
+          <p:cNvPr id="3" name="Notes Placeholder 2"/>
+          <p:cNvSpPr>
+            <a:spLocks noGrp="1"/>
+          </p:cNvSpPr>
+          <p:nvPr>
+            <p:ph type="body" idx="1"/>
+          </p:nvPr>
+        </p:nvSpPr>
+        <p:spPr/>
+        <p:txBody>
+          <a:bodyPr/>
+          <a:lstStyle/>
+          <a:p>
+            <a:r>
+              <a:rPr lang="en-US" dirty="0"/>
+              <a:t>[PriceAction1]</a:t>
+            </a:r>
+          </a:p>
+        </p:txBody>
+      </p:sp>
+      <p:sp>
+        <p:nvSpPr>
+          <p:cNvPr id="4" name="Slide Number Placeholder 3"/>
+          <p:cNvSpPr>
+            <a:spLocks noGrp="1"/>
+          </p:cNvSpPr>
+          <p:nvPr>
+            <p:ph type="sldNum" sz="quarter" idx="5"/>
+          </p:nvPr>
+        </p:nvSpPr>
+        <p:spPr/>
+        <p:txBody>
+          <a:bodyPr/>
+          <a:lstStyle/>
+          <a:p>
+            <a:fld id="{898A681E-7C6D-40A2-857E-59A1F4D2B4AE}" type="slidenum">
+              <a:rPr lang="en-US" smtClean="0"/>
+              <a:t>2</a:t>
+            </a:fld>
+            <a:endParaRPr lang="en-US"/>
+          </a:p>
+        </p:txBody>
+      </p:sp>
+    </p:spTree>
+    <p:extLst>
+      <p:ext uri="{BB962C8B-B14F-4D97-AF65-F5344CB8AC3E}">
+        <p14:creationId xmlns:p14="http://schemas.microsoft.com/office/powerpoint/2010/main" val="3570575979"/>
       </p:ext>
     </p:extLst>
   </p:cSld>
@@ -4729,6 +4817,451 @@
     <p:extLst>
       <p:ext uri="{BB962C8B-B14F-4D97-AF65-F5344CB8AC3E}">
         <p14:creationId xmlns:p14="http://schemas.microsoft.com/office/powerpoint/2010/main" val="1627586739"/>
+      </p:ext>
+    </p:extLst>
+  </p:cSld>
+  <p:clrMapOvr>
+    <a:masterClrMapping/>
+  </p:clrMapOvr>
+</p:sld>
+</file>
+
+<file path=ppt/slides/slide2.xml><?xml version="1.0" encoding="utf-8"?>
+<p:sld xmlns:a="http://schemas.openxmlformats.org/drawingml/2006/main" xmlns:r="http://schemas.openxmlformats.org/officeDocument/2006/relationships" xmlns:p="http://schemas.openxmlformats.org/presentationml/2006/main">
+  <p:cSld>
+    <p:spTree>
+      <p:nvGrpSpPr>
+        <p:cNvPr id="1" name=""/>
+        <p:cNvGrpSpPr/>
+        <p:nvPr/>
+      </p:nvGrpSpPr>
+      <p:grpSpPr>
+        <a:xfrm>
+          <a:off x="0" y="0"/>
+          <a:ext cx="0" cy="0"/>
+          <a:chOff x="0" y="0"/>
+          <a:chExt cx="0" cy="0"/>
+        </a:xfrm>
+      </p:grpSpPr>
+      <p:cxnSp>
+        <p:nvCxnSpPr>
+          <p:cNvPr id="2" name="Straight Connector 1">
+            <a:extLst>
+              <a:ext uri="{FF2B5EF4-FFF2-40B4-BE49-F238E27FC236}">
+                <a16:creationId xmlns:a16="http://schemas.microsoft.com/office/drawing/2014/main" id="{2EE9DB66-E525-7928-5856-DDE59179151C}"/>
+              </a:ext>
+            </a:extLst>
+          </p:cNvPr>
+          <p:cNvCxnSpPr>
+            <a:cxnSpLocks/>
+          </p:cNvCxnSpPr>
+          <p:nvPr/>
+        </p:nvCxnSpPr>
+        <p:spPr>
+          <a:xfrm>
+            <a:off x="1482383" y="1461762"/>
+            <a:ext cx="0" cy="4040222"/>
+          </a:xfrm>
+          <a:prstGeom prst="line">
+            <a:avLst/>
+          </a:prstGeom>
+        </p:spPr>
+        <p:style>
+          <a:lnRef idx="2">
+            <a:schemeClr val="dk1"/>
+          </a:lnRef>
+          <a:fillRef idx="0">
+            <a:schemeClr val="dk1"/>
+          </a:fillRef>
+          <a:effectRef idx="1">
+            <a:schemeClr val="dk1"/>
+          </a:effectRef>
+          <a:fontRef idx="minor">
+            <a:schemeClr val="tx1"/>
+          </a:fontRef>
+        </p:style>
+      </p:cxnSp>
+      <p:sp>
+        <p:nvSpPr>
+          <p:cNvPr id="3" name="Rectangle 2">
+            <a:extLst>
+              <a:ext uri="{FF2B5EF4-FFF2-40B4-BE49-F238E27FC236}">
+                <a16:creationId xmlns:a16="http://schemas.microsoft.com/office/drawing/2014/main" id="{F0ADC2CC-D930-A98E-4E97-1CEAB2F50A38}"/>
+              </a:ext>
+            </a:extLst>
+          </p:cNvPr>
+          <p:cNvSpPr/>
+          <p:nvPr/>
+        </p:nvSpPr>
+        <p:spPr>
+          <a:xfrm>
+            <a:off x="1284587" y="1915720"/>
+            <a:ext cx="395591" cy="3586264"/>
+          </a:xfrm>
+          <a:prstGeom prst="rect">
+            <a:avLst/>
+          </a:prstGeom>
+          <a:solidFill>
+            <a:schemeClr val="accent3">
+              <a:lumMod val="20000"/>
+              <a:lumOff val="80000"/>
+            </a:schemeClr>
+          </a:solidFill>
+        </p:spPr>
+        <p:style>
+          <a:lnRef idx="2">
+            <a:schemeClr val="accent1">
+              <a:shade val="15000"/>
+            </a:schemeClr>
+          </a:lnRef>
+          <a:fillRef idx="1">
+            <a:schemeClr val="accent1"/>
+          </a:fillRef>
+          <a:effectRef idx="0">
+            <a:schemeClr val="accent1"/>
+          </a:effectRef>
+          <a:fontRef idx="minor">
+            <a:schemeClr val="lt1"/>
+          </a:fontRef>
+        </p:style>
+        <p:txBody>
+          <a:bodyPr rtlCol="0" anchor="ctr"/>
+          <a:lstStyle/>
+          <a:p>
+            <a:pPr algn="ctr"/>
+            <a:endParaRPr lang="en-US"/>
+          </a:p>
+        </p:txBody>
+      </p:sp>
+      <p:cxnSp>
+        <p:nvCxnSpPr>
+          <p:cNvPr id="5" name="Straight Connector 4">
+            <a:extLst>
+              <a:ext uri="{FF2B5EF4-FFF2-40B4-BE49-F238E27FC236}">
+                <a16:creationId xmlns:a16="http://schemas.microsoft.com/office/drawing/2014/main" id="{0FA572E9-DEEC-9557-4653-F472C037FE81}"/>
+              </a:ext>
+            </a:extLst>
+          </p:cNvPr>
+          <p:cNvCxnSpPr>
+            <a:cxnSpLocks/>
+          </p:cNvCxnSpPr>
+          <p:nvPr/>
+        </p:nvCxnSpPr>
+        <p:spPr>
+          <a:xfrm>
+            <a:off x="7099907" y="1461762"/>
+            <a:ext cx="0" cy="4040222"/>
+          </a:xfrm>
+          <a:prstGeom prst="line">
+            <a:avLst/>
+          </a:prstGeom>
+        </p:spPr>
+        <p:style>
+          <a:lnRef idx="2">
+            <a:schemeClr val="dk1"/>
+          </a:lnRef>
+          <a:fillRef idx="0">
+            <a:schemeClr val="dk1"/>
+          </a:fillRef>
+          <a:effectRef idx="1">
+            <a:schemeClr val="dk1"/>
+          </a:effectRef>
+          <a:fontRef idx="minor">
+            <a:schemeClr val="tx1"/>
+          </a:fontRef>
+        </p:style>
+      </p:cxnSp>
+      <p:sp>
+        <p:nvSpPr>
+          <p:cNvPr id="6" name="Rectangle 5">
+            <a:extLst>
+              <a:ext uri="{FF2B5EF4-FFF2-40B4-BE49-F238E27FC236}">
+                <a16:creationId xmlns:a16="http://schemas.microsoft.com/office/drawing/2014/main" id="{CDFFB13D-E801-BCA0-7EB0-E7A058720598}"/>
+              </a:ext>
+            </a:extLst>
+          </p:cNvPr>
+          <p:cNvSpPr/>
+          <p:nvPr/>
+        </p:nvSpPr>
+        <p:spPr>
+          <a:xfrm>
+            <a:off x="6902111" y="1461762"/>
+            <a:ext cx="395591" cy="3586264"/>
+          </a:xfrm>
+          <a:prstGeom prst="rect">
+            <a:avLst/>
+          </a:prstGeom>
+          <a:solidFill>
+            <a:schemeClr val="accent2">
+              <a:lumMod val="20000"/>
+              <a:lumOff val="80000"/>
+            </a:schemeClr>
+          </a:solidFill>
+        </p:spPr>
+        <p:style>
+          <a:lnRef idx="2">
+            <a:schemeClr val="accent1">
+              <a:shade val="15000"/>
+            </a:schemeClr>
+          </a:lnRef>
+          <a:fillRef idx="1">
+            <a:schemeClr val="accent1"/>
+          </a:fillRef>
+          <a:effectRef idx="0">
+            <a:schemeClr val="accent1"/>
+          </a:effectRef>
+          <a:fontRef idx="minor">
+            <a:schemeClr val="lt1"/>
+          </a:fontRef>
+        </p:style>
+        <p:txBody>
+          <a:bodyPr rtlCol="0" anchor="ctr"/>
+          <a:lstStyle/>
+          <a:p>
+            <a:pPr algn="ctr"/>
+            <a:endParaRPr lang="en-US"/>
+          </a:p>
+        </p:txBody>
+      </p:sp>
+      <p:sp>
+        <p:nvSpPr>
+          <p:cNvPr id="7" name="TextBox 6">
+            <a:extLst>
+              <a:ext uri="{FF2B5EF4-FFF2-40B4-BE49-F238E27FC236}">
+                <a16:creationId xmlns:a16="http://schemas.microsoft.com/office/drawing/2014/main" id="{B4090BB1-9292-4D4E-4834-F4BEE832A8E3}"/>
+              </a:ext>
+            </a:extLst>
+          </p:cNvPr>
+          <p:cNvSpPr txBox="1"/>
+          <p:nvPr/>
+        </p:nvSpPr>
+        <p:spPr>
+          <a:xfrm>
+            <a:off x="4179890" y="423199"/>
+            <a:ext cx="3832220" cy="523220"/>
+          </a:xfrm>
+          <a:prstGeom prst="rect">
+            <a:avLst/>
+          </a:prstGeom>
+          <a:solidFill>
+            <a:schemeClr val="bg2"/>
+          </a:solidFill>
+        </p:spPr>
+        <p:txBody>
+          <a:bodyPr wrap="square" rtlCol="0">
+            <a:spAutoFit/>
+          </a:bodyPr>
+          <a:lstStyle/>
+          <a:p>
+            <a:pPr algn="ctr"/>
+            <a:r>
+              <a:rPr lang="en-US" sz="2800" b="1" dirty="0">
+                <a:solidFill>
+                  <a:sysClr val="windowText" lastClr="000000"/>
+                </a:solidFill>
+                <a:latin typeface="Aptos Black" panose="020B0004020202020204" pitchFamily="34" charset="0"/>
+              </a:rPr>
+              <a:t>Candle Without Wig</a:t>
+            </a:r>
+          </a:p>
+        </p:txBody>
+      </p:sp>
+      <p:sp>
+        <p:nvSpPr>
+          <p:cNvPr id="8" name="Rectangle 7">
+            <a:extLst>
+              <a:ext uri="{FF2B5EF4-FFF2-40B4-BE49-F238E27FC236}">
+                <a16:creationId xmlns:a16="http://schemas.microsoft.com/office/drawing/2014/main" id="{0268E898-73D6-1E55-3294-785A06D17EE1}"/>
+              </a:ext>
+            </a:extLst>
+          </p:cNvPr>
+          <p:cNvSpPr/>
+          <p:nvPr/>
+        </p:nvSpPr>
+        <p:spPr>
+          <a:xfrm>
+            <a:off x="6242909" y="1295949"/>
+            <a:ext cx="5629531" cy="4698086"/>
+          </a:xfrm>
+          <a:prstGeom prst="rect">
+            <a:avLst/>
+          </a:prstGeom>
+          <a:solidFill>
+            <a:schemeClr val="accent1">
+              <a:alpha val="0"/>
+            </a:schemeClr>
+          </a:solidFill>
+          <a:ln>
+            <a:solidFill>
+              <a:srgbClr val="000000"/>
+            </a:solidFill>
+          </a:ln>
+        </p:spPr>
+        <p:style>
+          <a:lnRef idx="2">
+            <a:schemeClr val="accent1">
+              <a:shade val="15000"/>
+            </a:schemeClr>
+          </a:lnRef>
+          <a:fillRef idx="1">
+            <a:schemeClr val="accent1"/>
+          </a:fillRef>
+          <a:effectRef idx="0">
+            <a:schemeClr val="accent1"/>
+          </a:effectRef>
+          <a:fontRef idx="minor">
+            <a:schemeClr val="lt1"/>
+          </a:fontRef>
+        </p:style>
+        <p:txBody>
+          <a:bodyPr rtlCol="0" anchor="ctr"/>
+          <a:lstStyle/>
+          <a:p>
+            <a:pPr algn="ctr"/>
+            <a:endParaRPr lang="en-US"/>
+          </a:p>
+        </p:txBody>
+      </p:sp>
+      <p:sp>
+        <p:nvSpPr>
+          <p:cNvPr id="9" name="Rectangle 8">
+            <a:extLst>
+              <a:ext uri="{FF2B5EF4-FFF2-40B4-BE49-F238E27FC236}">
+                <a16:creationId xmlns:a16="http://schemas.microsoft.com/office/drawing/2014/main" id="{18324875-EB1C-2204-8B42-B5419109EF52}"/>
+              </a:ext>
+            </a:extLst>
+          </p:cNvPr>
+          <p:cNvSpPr/>
+          <p:nvPr/>
+        </p:nvSpPr>
+        <p:spPr>
+          <a:xfrm>
+            <a:off x="613378" y="1295949"/>
+            <a:ext cx="5629531" cy="4698086"/>
+          </a:xfrm>
+          <a:prstGeom prst="rect">
+            <a:avLst/>
+          </a:prstGeom>
+          <a:solidFill>
+            <a:schemeClr val="accent1">
+              <a:alpha val="0"/>
+            </a:schemeClr>
+          </a:solidFill>
+          <a:ln>
+            <a:solidFill>
+              <a:srgbClr val="000000"/>
+            </a:solidFill>
+          </a:ln>
+        </p:spPr>
+        <p:style>
+          <a:lnRef idx="2">
+            <a:schemeClr val="accent1">
+              <a:shade val="15000"/>
+            </a:schemeClr>
+          </a:lnRef>
+          <a:fillRef idx="1">
+            <a:schemeClr val="accent1"/>
+          </a:fillRef>
+          <a:effectRef idx="0">
+            <a:schemeClr val="accent1"/>
+          </a:effectRef>
+          <a:fontRef idx="minor">
+            <a:schemeClr val="lt1"/>
+          </a:fontRef>
+        </p:style>
+        <p:txBody>
+          <a:bodyPr rtlCol="0" anchor="ctr"/>
+          <a:lstStyle/>
+          <a:p>
+            <a:pPr algn="ctr"/>
+            <a:endParaRPr lang="en-US"/>
+          </a:p>
+        </p:txBody>
+      </p:sp>
+      <p:sp>
+        <p:nvSpPr>
+          <p:cNvPr id="10" name="TextBox 9">
+            <a:extLst>
+              <a:ext uri="{FF2B5EF4-FFF2-40B4-BE49-F238E27FC236}">
+                <a16:creationId xmlns:a16="http://schemas.microsoft.com/office/drawing/2014/main" id="{744EDA1D-A67A-9AFB-F312-1C578A0F0541}"/>
+              </a:ext>
+            </a:extLst>
+          </p:cNvPr>
+          <p:cNvSpPr txBox="1"/>
+          <p:nvPr/>
+        </p:nvSpPr>
+        <p:spPr>
+          <a:xfrm>
+            <a:off x="1875976" y="3310364"/>
+            <a:ext cx="3509935" cy="523220"/>
+          </a:xfrm>
+          <a:prstGeom prst="rect">
+            <a:avLst/>
+          </a:prstGeom>
+          <a:noFill/>
+        </p:spPr>
+        <p:txBody>
+          <a:bodyPr wrap="square" rtlCol="0">
+            <a:spAutoFit/>
+          </a:bodyPr>
+          <a:lstStyle/>
+          <a:p>
+            <a:pPr algn="r"/>
+            <a:r>
+              <a:rPr lang="en-US" sz="2800" dirty="0">
+                <a:solidFill>
+                  <a:sysClr val="windowText" lastClr="000000"/>
+                </a:solidFill>
+              </a:rPr>
+              <a:t>Bullish Price Action</a:t>
+            </a:r>
+          </a:p>
+        </p:txBody>
+      </p:sp>
+      <p:sp>
+        <p:nvSpPr>
+          <p:cNvPr id="11" name="TextBox 10">
+            <a:extLst>
+              <a:ext uri="{FF2B5EF4-FFF2-40B4-BE49-F238E27FC236}">
+                <a16:creationId xmlns:a16="http://schemas.microsoft.com/office/drawing/2014/main" id="{5A0A347B-152F-5CC4-1445-05EB909D6503}"/>
+              </a:ext>
+            </a:extLst>
+          </p:cNvPr>
+          <p:cNvSpPr txBox="1"/>
+          <p:nvPr/>
+        </p:nvSpPr>
+        <p:spPr>
+          <a:xfrm>
+            <a:off x="7632535" y="3310364"/>
+            <a:ext cx="3509935" cy="523220"/>
+          </a:xfrm>
+          <a:prstGeom prst="rect">
+            <a:avLst/>
+          </a:prstGeom>
+          <a:noFill/>
+        </p:spPr>
+        <p:txBody>
+          <a:bodyPr wrap="square" rtlCol="0">
+            <a:spAutoFit/>
+          </a:bodyPr>
+          <a:lstStyle/>
+          <a:p>
+            <a:pPr algn="r"/>
+            <a:r>
+              <a:rPr lang="en-US" sz="2800" dirty="0">
+                <a:solidFill>
+                  <a:sysClr val="windowText" lastClr="000000"/>
+                </a:solidFill>
+              </a:rPr>
+              <a:t>Bearish Price Action</a:t>
+            </a:r>
+          </a:p>
+        </p:txBody>
+      </p:sp>
+    </p:spTree>
+    <p:extLst>
+      <p:ext uri="{BB962C8B-B14F-4D97-AF65-F5344CB8AC3E}">
+        <p14:creationId xmlns:p14="http://schemas.microsoft.com/office/powerpoint/2010/main" val="2083976301"/>
       </p:ext>
     </p:extLst>
   </p:cSld>

</xml_diff>